<commit_message>
Update Steven Ellman proposal: standalone Full-Service Marketing Growth, revenue $2.4M → $4M
Co-Authored-By: Claude Sonnet 4.6 <noreply@anthropic.com>
</commit_message>
<xml_diff>
--- a/law-office-of-steven-ellman/Law_Office_of_Steven_Ellman_June2_2026_Proposal.pptx
+++ b/law-office-of-steven-ellman/Law_Office_of_Steven_Ellman_June2_2026_Proposal.pptx
@@ -5860,7 +5860,7 @@
                 </a:solidFill>
                 <a:latin typeface="Calibri"/>
               </a:rPr>
-              <a:t>Your Growth Plan: 3 Priorities to Reach $50,000/Month</a:t>
+              <a:t>Your Growth Plan: 3 Priorities to Reach $4M / Year</a:t>
             </a:r>
           </a:p>
         </p:txBody>
@@ -6094,7 +6094,7 @@
                 </a:solidFill>
                 <a:latin typeface="Calibri"/>
               </a:rPr>
-              <a:t>$300K → $600K+ revenue</a:t>
+              <a:t>$2.4M → $4M revenue</a:t>
             </a:r>
           </a:p>
         </p:txBody>
@@ -8767,7 +8767,7 @@
                 </a:solidFill>
                 <a:latin typeface="Calibri"/>
               </a:rPr>
-              <a:t>FULL SERVICE MARKETING ESSENTIALS</a:t>
+              <a:t>FULL SERVICE MARKETING GROWTH</a:t>
             </a:r>
           </a:p>
         </p:txBody>
@@ -8957,306 +8957,6 @@
         </p:nvSpPr>
         <p:spPr>
           <a:xfrm>
-            <a:off x="201168" y="2139696"/>
-            <a:ext cx="4133087" cy="1024128"/>
-          </a:xfrm>
-          <a:prstGeom prst="rect">
-            <a:avLst/>
-          </a:prstGeom>
-          <a:solidFill>
-            <a:srgbClr val="FFFFFF"/>
-          </a:solidFill>
-          <a:ln>
-            <a:solidFill>
-              <a:srgbClr val="FFFFFF"/>
-            </a:solidFill>
-          </a:ln>
-        </p:spPr>
-        <p:style>
-          <a:lnRef idx="1">
-            <a:schemeClr val="accent1"/>
-          </a:lnRef>
-          <a:fillRef idx="3">
-            <a:schemeClr val="accent1"/>
-          </a:fillRef>
-          <a:effectRef idx="2">
-            <a:schemeClr val="accent1"/>
-          </a:effectRef>
-          <a:fontRef idx="minor">
-            <a:schemeClr val="lt1"/>
-          </a:fontRef>
-        </p:style>
-        <p:txBody>
-          <a:bodyPr rtlCol="0" anchor="ctr"/>
-          <a:lstStyle/>
-          <a:p>
-            <a:pPr algn="ctr"/>
-          </a:p>
-        </p:txBody>
-      </p:sp>
-      <p:sp>
-        <p:nvSpPr>
-          <p:cNvPr id="14" name="Rectangle 13"/>
-          <p:cNvSpPr/>
-          <p:nvPr/>
-        </p:nvSpPr>
-        <p:spPr>
-          <a:xfrm>
-            <a:off x="201168" y="2139696"/>
-            <a:ext cx="182880" cy="1024128"/>
-          </a:xfrm>
-          <a:prstGeom prst="rect">
-            <a:avLst/>
-          </a:prstGeom>
-          <a:solidFill>
-            <a:srgbClr val="6D28D9"/>
-          </a:solidFill>
-          <a:ln>
-            <a:solidFill>
-              <a:srgbClr val="FFFFFF"/>
-            </a:solidFill>
-          </a:ln>
-        </p:spPr>
-        <p:style>
-          <a:lnRef idx="1">
-            <a:schemeClr val="accent1"/>
-          </a:lnRef>
-          <a:fillRef idx="3">
-            <a:schemeClr val="accent1"/>
-          </a:fillRef>
-          <a:effectRef idx="2">
-            <a:schemeClr val="accent1"/>
-          </a:effectRef>
-          <a:fontRef idx="minor">
-            <a:schemeClr val="lt1"/>
-          </a:fontRef>
-        </p:style>
-        <p:txBody>
-          <a:bodyPr rtlCol="0" anchor="ctr"/>
-          <a:lstStyle/>
-          <a:p>
-            <a:pPr algn="ctr"/>
-          </a:p>
-        </p:txBody>
-      </p:sp>
-      <p:sp>
-        <p:nvSpPr>
-          <p:cNvPr id="15" name="TextBox 14"/>
-          <p:cNvSpPr txBox="1"/>
-          <p:nvPr/>
-        </p:nvSpPr>
-        <p:spPr>
-          <a:xfrm>
-            <a:off x="475488" y="2231136"/>
-            <a:ext cx="3803904" cy="201168"/>
-          </a:xfrm>
-          <a:prstGeom prst="rect">
-            <a:avLst/>
-          </a:prstGeom>
-          <a:noFill/>
-        </p:spPr>
-        <p:txBody>
-          <a:bodyPr wrap="square"/>
-          <a:lstStyle/>
-          <a:p>
-            <a:pPr algn="l"/>
-            <a:r>
-              <a:rPr sz="800" b="1" i="0">
-                <a:solidFill>
-                  <a:srgbClr val="6D28D9"/>
-                </a:solidFill>
-                <a:latin typeface="Calibri"/>
-              </a:rPr>
-              <a:t>ELITE COACH</a:t>
-            </a:r>
-          </a:p>
-        </p:txBody>
-      </p:sp>
-      <p:sp>
-        <p:nvSpPr>
-          <p:cNvPr id="16" name="TextBox 15"/>
-          <p:cNvSpPr txBox="1"/>
-          <p:nvPr/>
-        </p:nvSpPr>
-        <p:spPr>
-          <a:xfrm>
-            <a:off x="475488" y="2414015"/>
-            <a:ext cx="1828800" cy="438912"/>
-          </a:xfrm>
-          <a:prstGeom prst="rect">
-            <a:avLst/>
-          </a:prstGeom>
-          <a:noFill/>
-        </p:spPr>
-        <p:txBody>
-          <a:bodyPr wrap="square"/>
-          <a:lstStyle/>
-          <a:p>
-            <a:pPr algn="l"/>
-            <a:r>
-              <a:rPr sz="3200" b="1" i="0">
-                <a:solidFill>
-                  <a:srgbClr val="0D1F3C"/>
-                </a:solidFill>
-                <a:latin typeface="Calibri"/>
-              </a:rPr>
-              <a:t>$2,600</a:t>
-            </a:r>
-          </a:p>
-        </p:txBody>
-      </p:sp>
-      <p:sp>
-        <p:nvSpPr>
-          <p:cNvPr id="17" name="TextBox 16"/>
-          <p:cNvSpPr txBox="1"/>
-          <p:nvPr/>
-        </p:nvSpPr>
-        <p:spPr>
-          <a:xfrm>
-            <a:off x="1865376" y="2523744"/>
-            <a:ext cx="420624" cy="256032"/>
-          </a:xfrm>
-          <a:prstGeom prst="rect">
-            <a:avLst/>
-          </a:prstGeom>
-          <a:noFill/>
-        </p:spPr>
-        <p:txBody>
-          <a:bodyPr wrap="square"/>
-          <a:lstStyle/>
-          <a:p>
-            <a:pPr algn="l"/>
-            <a:r>
-              <a:rPr sz="1100" b="0" i="0">
-                <a:solidFill>
-                  <a:srgbClr val="64748B"/>
-                </a:solidFill>
-                <a:latin typeface="Calibri"/>
-              </a:rPr>
-              <a:t>/mo</a:t>
-            </a:r>
-          </a:p>
-        </p:txBody>
-      </p:sp>
-      <p:sp>
-        <p:nvSpPr>
-          <p:cNvPr id="18" name="TextBox 17"/>
-          <p:cNvSpPr txBox="1"/>
-          <p:nvPr/>
-        </p:nvSpPr>
-        <p:spPr>
-          <a:xfrm>
-            <a:off x="2322576" y="2542032"/>
-            <a:ext cx="914400" cy="237744"/>
-          </a:xfrm>
-          <a:prstGeom prst="rect">
-            <a:avLst/>
-          </a:prstGeom>
-          <a:noFill/>
-        </p:spPr>
-        <p:txBody>
-          <a:bodyPr wrap="square"/>
-          <a:lstStyle/>
-          <a:p>
-            <a:pPr algn="l"/>
-            <a:r>
-              <a:rPr sz="1100" b="0" i="0">
-                <a:solidFill>
-                  <a:srgbClr val="334155"/>
-                </a:solidFill>
-                <a:latin typeface="Calibri"/>
-              </a:rPr>
-              <a:t>$3,497/mo</a:t>
-            </a:r>
-          </a:p>
-        </p:txBody>
-      </p:sp>
-      <p:sp>
-        <p:nvSpPr>
-          <p:cNvPr id="19" name="Rectangle 18"/>
-          <p:cNvSpPr/>
-          <p:nvPr/>
-        </p:nvSpPr>
-        <p:spPr>
-          <a:xfrm>
-            <a:off x="2322576" y="2642615"/>
-            <a:ext cx="804672" cy="9144"/>
-          </a:xfrm>
-          <a:prstGeom prst="rect">
-            <a:avLst/>
-          </a:prstGeom>
-          <a:solidFill>
-            <a:srgbClr val="334155"/>
-          </a:solidFill>
-          <a:ln>
-            <a:solidFill>
-              <a:srgbClr val="FFFFFF"/>
-            </a:solidFill>
-          </a:ln>
-        </p:spPr>
-        <p:style>
-          <a:lnRef idx="1">
-            <a:schemeClr val="accent1"/>
-          </a:lnRef>
-          <a:fillRef idx="3">
-            <a:schemeClr val="accent1"/>
-          </a:fillRef>
-          <a:effectRef idx="2">
-            <a:schemeClr val="accent1"/>
-          </a:effectRef>
-          <a:fontRef idx="minor">
-            <a:schemeClr val="lt1"/>
-          </a:fontRef>
-        </p:style>
-        <p:txBody>
-          <a:bodyPr rtlCol="0" anchor="ctr"/>
-          <a:lstStyle/>
-          <a:p>
-            <a:pPr algn="ctr"/>
-          </a:p>
-        </p:txBody>
-      </p:sp>
-      <p:sp>
-        <p:nvSpPr>
-          <p:cNvPr id="20" name="TextBox 19"/>
-          <p:cNvSpPr txBox="1"/>
-          <p:nvPr/>
-        </p:nvSpPr>
-        <p:spPr>
-          <a:xfrm>
-            <a:off x="475488" y="2907791"/>
-            <a:ext cx="3803904" cy="201168"/>
-          </a:xfrm>
-          <a:prstGeom prst="rect">
-            <a:avLst/>
-          </a:prstGeom>
-          <a:noFill/>
-        </p:spPr>
-        <p:txBody>
-          <a:bodyPr wrap="square"/>
-          <a:lstStyle/>
-          <a:p>
-            <a:pPr algn="l"/>
-            <a:r>
-              <a:rPr sz="800" b="0" i="0">
-                <a:solidFill>
-                  <a:srgbClr val="64748B"/>
-                </a:solidFill>
-                <a:latin typeface="Calibri"/>
-              </a:rPr>
-              <a:t>Weekly coaching · Masterminds · Intake framework · Workshops</a:t>
-            </a:r>
-          </a:p>
-        </p:txBody>
-      </p:sp>
-      <p:sp>
-        <p:nvSpPr>
-          <p:cNvPr id="21" name="Rectangle 20"/>
-          <p:cNvSpPr/>
-          <p:nvPr/>
-        </p:nvSpPr>
-        <p:spPr>
-          <a:xfrm>
             <a:off x="201168" y="3255264"/>
             <a:ext cx="4133087" cy="658368"/>
           </a:xfrm>
@@ -9296,7 +8996,7 @@
       </p:sp>
       <p:sp>
         <p:nvSpPr>
-          <p:cNvPr id="22" name="TextBox 21"/>
+          <p:cNvPr id="14" name="TextBox 13"/>
           <p:cNvSpPr txBox="1"/>
           <p:nvPr/>
         </p:nvSpPr>
@@ -9329,7 +9029,7 @@
       </p:sp>
       <p:sp>
         <p:nvSpPr>
-          <p:cNvPr id="23" name="TextBox 22"/>
+          <p:cNvPr id="15" name="TextBox 14"/>
           <p:cNvSpPr txBox="1"/>
           <p:nvPr/>
         </p:nvSpPr>
@@ -9355,14 +9055,14 @@
                 </a:solidFill>
                 <a:latin typeface="Calibri"/>
               </a:rPr>
-              <a:t>$5,997 / mo</a:t>
-            </a:r>
-          </a:p>
-        </p:txBody>
-      </p:sp>
-      <p:sp>
-        <p:nvSpPr>
-          <p:cNvPr id="24" name="TextBox 23"/>
+              <a:t>$3,397 / mo</a:t>
+            </a:r>
+          </a:p>
+        </p:txBody>
+      </p:sp>
+      <p:sp>
+        <p:nvSpPr>
+          <p:cNvPr id="16" name="TextBox 15"/>
           <p:cNvSpPr txBox="1"/>
           <p:nvPr/>
         </p:nvSpPr>
@@ -9388,14 +9088,14 @@
                 </a:solidFill>
                 <a:latin typeface="Calibri"/>
               </a:rPr>
-              <a:t>Save $897/mo by bundling</a:t>
-            </a:r>
-          </a:p>
-        </p:txBody>
-      </p:sp>
-      <p:sp>
-        <p:nvSpPr>
-          <p:cNvPr id="25" name="Rectangle 24"/>
+              <a:t>Standalone solution</a:t>
+            </a:r>
+          </a:p>
+        </p:txBody>
+      </p:sp>
+      <p:sp>
+        <p:nvSpPr>
+          <p:cNvPr id="17" name="Rectangle 16"/>
           <p:cNvSpPr/>
           <p:nvPr/>
         </p:nvSpPr>
@@ -9440,7 +9140,7 @@
       </p:sp>
       <p:sp>
         <p:nvSpPr>
-          <p:cNvPr id="26" name="TextBox 25"/>
+          <p:cNvPr id="18" name="TextBox 17"/>
           <p:cNvSpPr txBox="1"/>
           <p:nvPr/>
         </p:nvSpPr>
@@ -9473,7 +9173,7 @@
       </p:sp>
       <p:sp>
         <p:nvSpPr>
-          <p:cNvPr id="27" name="Rectangle 26"/>
+          <p:cNvPr id="19" name="Rectangle 18"/>
           <p:cNvSpPr/>
           <p:nvPr/>
         </p:nvSpPr>
@@ -9518,7 +9218,7 @@
       </p:sp>
       <p:sp>
         <p:nvSpPr>
-          <p:cNvPr id="28" name="TextBox 27"/>
+          <p:cNvPr id="20" name="TextBox 19"/>
           <p:cNvSpPr txBox="1"/>
           <p:nvPr/>
         </p:nvSpPr>
@@ -9551,7 +9251,7 @@
       </p:sp>
       <p:sp>
         <p:nvSpPr>
-          <p:cNvPr id="29" name="TextBox 28"/>
+          <p:cNvPr id="21" name="TextBox 20"/>
           <p:cNvSpPr txBox="1"/>
           <p:nvPr/>
         </p:nvSpPr>
@@ -9584,7 +9284,7 @@
       </p:sp>
       <p:sp>
         <p:nvSpPr>
-          <p:cNvPr id="30" name="TextBox 29"/>
+          <p:cNvPr id="22" name="TextBox 21"/>
           <p:cNvSpPr txBox="1"/>
           <p:nvPr/>
         </p:nvSpPr>
@@ -9617,7 +9317,7 @@
       </p:sp>
       <p:sp>
         <p:nvSpPr>
-          <p:cNvPr id="31" name="Rectangle 30"/>
+          <p:cNvPr id="23" name="Rectangle 22"/>
           <p:cNvSpPr/>
           <p:nvPr/>
         </p:nvSpPr>
@@ -9662,7 +9362,7 @@
       </p:sp>
       <p:sp>
         <p:nvSpPr>
-          <p:cNvPr id="32" name="TextBox 31"/>
+          <p:cNvPr id="24" name="TextBox 23"/>
           <p:cNvSpPr txBox="1"/>
           <p:nvPr/>
         </p:nvSpPr>
@@ -9695,7 +9395,7 @@
       </p:sp>
       <p:sp>
         <p:nvSpPr>
-          <p:cNvPr id="33" name="TextBox 32"/>
+          <p:cNvPr id="25" name="TextBox 24"/>
           <p:cNvSpPr txBox="1"/>
           <p:nvPr/>
         </p:nvSpPr>
@@ -9728,7 +9428,7 @@
       </p:sp>
       <p:sp>
         <p:nvSpPr>
-          <p:cNvPr id="34" name="TextBox 33"/>
+          <p:cNvPr id="26" name="TextBox 25"/>
           <p:cNvSpPr txBox="1"/>
           <p:nvPr/>
         </p:nvSpPr>
@@ -9761,7 +9461,7 @@
       </p:sp>
       <p:sp>
         <p:nvSpPr>
-          <p:cNvPr id="35" name="TextBox 34"/>
+          <p:cNvPr id="27" name="TextBox 26"/>
           <p:cNvSpPr txBox="1"/>
           <p:nvPr/>
         </p:nvSpPr>
@@ -9794,7 +9494,7 @@
       </p:sp>
       <p:sp>
         <p:nvSpPr>
-          <p:cNvPr id="36" name="TextBox 35"/>
+          <p:cNvPr id="28" name="TextBox 27"/>
           <p:cNvSpPr txBox="1"/>
           <p:nvPr/>
         </p:nvSpPr>
@@ -9827,7 +9527,7 @@
       </p:sp>
       <p:sp>
         <p:nvSpPr>
-          <p:cNvPr id="37" name="Rectangle 36"/>
+          <p:cNvPr id="29" name="Rectangle 28"/>
           <p:cNvSpPr/>
           <p:nvPr/>
         </p:nvSpPr>
@@ -9872,7 +9572,7 @@
       </p:sp>
       <p:sp>
         <p:nvSpPr>
-          <p:cNvPr id="38" name="TextBox 37"/>
+          <p:cNvPr id="30" name="TextBox 29"/>
           <p:cNvSpPr txBox="1"/>
           <p:nvPr/>
         </p:nvSpPr>
@@ -9905,7 +9605,7 @@
       </p:sp>
       <p:sp>
         <p:nvSpPr>
-          <p:cNvPr id="39" name="TextBox 38"/>
+          <p:cNvPr id="31" name="TextBox 30"/>
           <p:cNvSpPr txBox="1"/>
           <p:nvPr/>
         </p:nvSpPr>
@@ -9938,7 +9638,7 @@
       </p:sp>
       <p:sp>
         <p:nvSpPr>
-          <p:cNvPr id="40" name="Rectangle 39"/>
+          <p:cNvPr id="32" name="Rectangle 31"/>
           <p:cNvSpPr/>
           <p:nvPr/>
         </p:nvSpPr>
@@ -9983,7 +9683,7 @@
       </p:sp>
       <p:sp>
         <p:nvSpPr>
-          <p:cNvPr id="41" name="TextBox 40"/>
+          <p:cNvPr id="33" name="TextBox 32"/>
           <p:cNvSpPr txBox="1"/>
           <p:nvPr/>
         </p:nvSpPr>
@@ -10016,7 +9716,7 @@
       </p:sp>
       <p:sp>
         <p:nvSpPr>
-          <p:cNvPr id="42" name="TextBox 41"/>
+          <p:cNvPr id="34" name="TextBox 33"/>
           <p:cNvSpPr txBox="1"/>
           <p:nvPr/>
         </p:nvSpPr>
@@ -10049,7 +9749,7 @@
       </p:sp>
       <p:sp>
         <p:nvSpPr>
-          <p:cNvPr id="43" name="Rectangle 42"/>
+          <p:cNvPr id="35" name="Rectangle 34"/>
           <p:cNvSpPr/>
           <p:nvPr/>
         </p:nvSpPr>
@@ -10094,7 +9794,7 @@
       </p:sp>
       <p:sp>
         <p:nvSpPr>
-          <p:cNvPr id="44" name="TextBox 43"/>
+          <p:cNvPr id="36" name="TextBox 35"/>
           <p:cNvSpPr txBox="1"/>
           <p:nvPr/>
         </p:nvSpPr>
@@ -10127,7 +9827,7 @@
       </p:sp>
       <p:sp>
         <p:nvSpPr>
-          <p:cNvPr id="45" name="TextBox 44"/>
+          <p:cNvPr id="37" name="TextBox 36"/>
           <p:cNvSpPr txBox="1"/>
           <p:nvPr/>
         </p:nvSpPr>
@@ -10160,7 +9860,7 @@
       </p:sp>
       <p:sp>
         <p:nvSpPr>
-          <p:cNvPr id="46" name="Rectangle 45"/>
+          <p:cNvPr id="38" name="Rectangle 37"/>
           <p:cNvSpPr/>
           <p:nvPr/>
         </p:nvSpPr>
@@ -10205,7 +9905,7 @@
       </p:sp>
       <p:sp>
         <p:nvSpPr>
-          <p:cNvPr id="47" name="TextBox 46"/>
+          <p:cNvPr id="39" name="TextBox 38"/>
           <p:cNvSpPr txBox="1"/>
           <p:nvPr/>
         </p:nvSpPr>
@@ -10238,7 +9938,7 @@
       </p:sp>
       <p:sp>
         <p:nvSpPr>
-          <p:cNvPr id="48" name="TextBox 47"/>
+          <p:cNvPr id="40" name="TextBox 39"/>
           <p:cNvSpPr txBox="1"/>
           <p:nvPr/>
         </p:nvSpPr>
@@ -10271,7 +9971,7 @@
       </p:sp>
       <p:sp>
         <p:nvSpPr>
-          <p:cNvPr id="49" name="Rectangle 48"/>
+          <p:cNvPr id="41" name="Rectangle 40"/>
           <p:cNvSpPr/>
           <p:nvPr/>
         </p:nvSpPr>
@@ -10316,7 +10016,7 @@
       </p:sp>
       <p:sp>
         <p:nvSpPr>
-          <p:cNvPr id="50" name="TextBox 49"/>
+          <p:cNvPr id="42" name="TextBox 41"/>
           <p:cNvSpPr txBox="1"/>
           <p:nvPr/>
         </p:nvSpPr>
@@ -10349,7 +10049,7 @@
       </p:sp>
       <p:sp>
         <p:nvSpPr>
-          <p:cNvPr id="51" name="TextBox 50"/>
+          <p:cNvPr id="43" name="TextBox 42"/>
           <p:cNvSpPr txBox="1"/>
           <p:nvPr/>
         </p:nvSpPr>
@@ -10382,7 +10082,7 @@
       </p:sp>
       <p:sp>
         <p:nvSpPr>
-          <p:cNvPr id="52" name="Rectangle 51"/>
+          <p:cNvPr id="44" name="Rectangle 43"/>
           <p:cNvSpPr/>
           <p:nvPr/>
         </p:nvSpPr>
@@ -10427,7 +10127,7 @@
       </p:sp>
       <p:sp>
         <p:nvSpPr>
-          <p:cNvPr id="53" name="TextBox 52"/>
+          <p:cNvPr id="45" name="TextBox 44"/>
           <p:cNvSpPr txBox="1"/>
           <p:nvPr/>
         </p:nvSpPr>
@@ -10460,7 +10160,7 @@
       </p:sp>
       <p:sp>
         <p:nvSpPr>
-          <p:cNvPr id="54" name="Rectangle 53"/>
+          <p:cNvPr id="46" name="Rectangle 45"/>
           <p:cNvSpPr/>
           <p:nvPr/>
         </p:nvSpPr>
@@ -10505,7 +10205,7 @@
       </p:sp>
       <p:sp>
         <p:nvSpPr>
-          <p:cNvPr id="55" name="TextBox 54"/>
+          <p:cNvPr id="47" name="TextBox 46"/>
           <p:cNvSpPr txBox="1"/>
           <p:nvPr/>
         </p:nvSpPr>
@@ -10538,7 +10238,7 @@
       </p:sp>
       <p:sp>
         <p:nvSpPr>
-          <p:cNvPr id="56" name="TextBox 55"/>
+          <p:cNvPr id="48" name="TextBox 47"/>
           <p:cNvSpPr txBox="1"/>
           <p:nvPr/>
         </p:nvSpPr>

</xml_diff>

<commit_message>
Add proposal PPTX: Law Office of Steven Ellman (June 2, 2026)
Updated for Full Service Marketing Growth at $8,997/mo standalone + $2,200
setup fee. ROI: conservative ~$22,500/mo (3.0x), aggressive ~$67,500/mo (4.5x).
Ad spend $7,500–$15,000/mo.

Co-Authored-By: Claude Sonnet 4.6 <noreply@anthropic.com>
</commit_message>
<xml_diff>
--- a/law-office-of-steven-ellman/Law_Office_of_Steven_Ellman_June2_2026_Proposal.pptx
+++ b/law-office-of-steven-ellman/Law_Office_of_Steven_Ellman_June2_2026_Proposal.pptx
@@ -4297,7 +4297,7 @@
                 </a:solidFill>
                 <a:latin typeface="Calibri"/>
               </a:rPr>
-              <a:t>Competitors own Google Ads &amp; LSA in Burlington Co. — this firm has zero paid presence</a:t>
+              <a:t>Competitors own Google Ads &amp; LSA in Burlington Co. — firm has zero paid presence</a:t>
             </a:r>
           </a:p>
         </p:txBody>
@@ -4453,7 +4453,7 @@
                 </a:solidFill>
                 <a:latin typeface="Calibri"/>
               </a:rPr>
-              <a:t>Baxter now leads in reviews (144 vs. 120) and holds top Burlington Co. DWI positions</a:t>
+              <a:t>Baxter leads in reviews (144 vs. 120) and holds top Burlington Co. DWI positions</a:t>
             </a:r>
           </a:p>
         </p:txBody>
@@ -4765,7 +4765,7 @@
                 </a:solidFill>
                 <a:latin typeface="Calibri"/>
               </a:rPr>
-              <a:t>4.9-star Google profile with 120 reviews — the strongest foundation in this market</a:t>
+              <a:t>4.9-star Google profile with 120 reviews — strongest foundation in this market</a:t>
             </a:r>
           </a:p>
         </p:txBody>
@@ -6394,7 +6394,7 @@
                 </a:solidFill>
                 <a:latin typeface="Calibri"/>
               </a:rPr>
-              <a:t>Turn Google into a DUI case pipeline without you</a:t>
+              <a:t>Turn Google into a DUI pipeline without you</a:t>
             </a:r>
           </a:p>
         </p:txBody>
@@ -6640,7 +6640,7 @@
                 </a:solidFill>
                 <a:latin typeface="Calibri"/>
               </a:rPr>
-              <a:t>Fix NAP across BBB and Martindale — unlock 3-pack</a:t>
+              <a:t>Fix NAP across BBB &amp; Martindale — unlock 3-pack</a:t>
             </a:r>
           </a:p>
         </p:txBody>
@@ -6763,7 +6763,7 @@
                 </a:solidFill>
                 <a:latin typeface="Calibri"/>
               </a:rPr>
-              <a:t>Launch retargeting — follow prospects after they visit</a:t>
+              <a:t>Launch Meta retargeting for South Jersey DUI leads</a:t>
             </a:r>
           </a:p>
         </p:txBody>
@@ -7153,7 +7153,7 @@
                 </a:solidFill>
                 <a:latin typeface="Calibri"/>
               </a:rPr>
-              <a:t>Cover Thu–Sat nights when DUI arrests happen most</a:t>
+              <a:t>Cover Thu–Sat nights when DUI arrests peak</a:t>
             </a:r>
           </a:p>
         </p:txBody>
@@ -7276,7 +7276,7 @@
                 </a:solidFill>
                 <a:latin typeface="Calibri"/>
               </a:rPr>
-              <a:t>Set a 5-minute form response standard — win early</a:t>
+              <a:t>Set 5-minute form response standard — win early</a:t>
             </a:r>
           </a:p>
         </p:txBody>
@@ -7645,7 +7645,7 @@
                 </a:solidFill>
                 <a:latin typeface="Calibri"/>
               </a:rPr>
-              <a:t>Build follow-up sequence for leads who don't sign fast</a:t>
+              <a:t>Build follow-up for leads who don’t sign fast</a:t>
             </a:r>
           </a:p>
         </p:txBody>
@@ -7912,7 +7912,7 @@
                 </a:solidFill>
                 <a:latin typeface="Calibri"/>
               </a:rPr>
-              <a:t>Document ops so the firm moves when you're in court</a:t>
+              <a:t>Document ops so the firm runs when you’re in court</a:t>
             </a:r>
           </a:p>
         </p:txBody>
@@ -8404,7 +8404,7 @@
                 </a:solidFill>
                 <a:latin typeface="Calibri"/>
               </a:rPr>
-              <a:t>Phase 2: intake coordinator scales capacity with you</a:t>
+              <a:t>Phase 2: intake coordinator scales with case volume</a:t>
             </a:r>
           </a:p>
         </p:txBody>
@@ -8767,7 +8767,7 @@
                 </a:solidFill>
                 <a:latin typeface="Calibri"/>
               </a:rPr>
-              <a:t>FULL SERVICE MARKETING GROWTH</a:t>
+              <a:t>FULL SERVICE MARKETING — GROWTH</a:t>
             </a:r>
           </a:p>
         </p:txBody>
@@ -8800,7 +8800,7 @@
                 </a:solidFill>
                 <a:latin typeface="Calibri"/>
               </a:rPr>
-              <a:t>$3,397</a:t>
+              <a:t>$8,997</a:t>
             </a:r>
           </a:p>
         </p:txBody>
@@ -8944,7 +8944,7 @@
                 </a:solidFill>
                 <a:latin typeface="Calibri"/>
               </a:rPr>
-              <a:t>Google Ads · LSA · Local SEO · Website Optimization · Reporting</a:t>
+              <a:t>Google Ads · LSA · Meta · Local SEO · Website Opt · $2,200 setup</a:t>
             </a:r>
           </a:p>
         </p:txBody>
@@ -9055,7 +9055,7 @@
                 </a:solidFill>
                 <a:latin typeface="Calibri"/>
               </a:rPr>
-              <a:t>$3,397 / mo</a:t>
+              <a:t>$8,997 / mo</a:t>
             </a:r>
           </a:p>
         </p:txBody>
@@ -9088,7 +9088,7 @@
                 </a:solidFill>
                 <a:latin typeface="Calibri"/>
               </a:rPr>
-              <a:t>Standalone solution</a:t>
+              <a:t>Add coaching &amp; save $1,600/mo</a:t>
             </a:r>
           </a:p>
         </p:txBody>
@@ -9166,7 +9166,7 @@
                 </a:solidFill>
                 <a:latin typeface="Calibri"/>
               </a:rPr>
-              <a:t>+ Recommended ad spend: $4,000–$5,500/mo paid directly to Google/LSA</a:t>
+              <a:t>+ Recommended ad spend: $7,500–$15,000/mo paid directly to Google/Meta</a:t>
             </a:r>
           </a:p>
         </p:txBody>
@@ -9388,7 +9388,7 @@
                 </a:solidFill>
                 <a:latin typeface="Calibri"/>
               </a:rPr>
-              <a:t>Conservative  (~3 cases/mo):</a:t>
+              <a:t>Conservative  (~5 cases/mo):</a:t>
             </a:r>
           </a:p>
         </p:txBody>
@@ -9421,7 +9421,7 @@
                 </a:solidFill>
                 <a:latin typeface="Calibri"/>
               </a:rPr>
-              <a:t>~$13,500 revenue · ~3.4× ROAS</a:t>
+              <a:t>~$22,500 revenue · ~3.0× ROAS</a:t>
             </a:r>
           </a:p>
         </p:txBody>
@@ -9454,7 +9454,7 @@
                 </a:solidFill>
                 <a:latin typeface="Calibri"/>
               </a:rPr>
-              <a:t>Aggressive  (~5 cases/mo):</a:t>
+              <a:t>Aggressive  (~15 cases/mo):</a:t>
             </a:r>
           </a:p>
         </p:txBody>
@@ -9487,7 +9487,7 @@
                 </a:solidFill>
                 <a:latin typeface="Calibri"/>
               </a:rPr>
-              <a:t>~$22,500 revenue · ~4.1× ROAS</a:t>
+              <a:t>~$67,500 revenue · ~4.5× ROAS</a:t>
             </a:r>
           </a:p>
         </p:txBody>
@@ -9853,7 +9853,7 @@
                 </a:solidFill>
                 <a:latin typeface="Calibri"/>
               </a:rPr>
-              <a:t>Intake protocol + after-hours coverage defined</a:t>
+              <a:t>Mobile PageSpeed + intake protocol defined</a:t>
             </a:r>
           </a:p>
         </p:txBody>
@@ -10075,7 +10075,7 @@
                 </a:solidFill>
                 <a:latin typeface="Calibri"/>
               </a:rPr>
-              <a:t>Coach reviews KPIs; Phase 2 roadmap confirmed</a:t>
+              <a:t>Dashboard reviewed; Phase 2 roadmap confirmed</a:t>
             </a:r>
           </a:p>
         </p:txBody>
@@ -10153,7 +10153,7 @@
                 </a:solidFill>
                 <a:latin typeface="Calibri"/>
               </a:rPr>
-              <a:t>"The leads exist — Christopher Baxter and Levow are capturing them right now while this firm's paid presence sits empty."</a:t>
+              <a:t>“The leads exist — Christopher Baxter and Levow DWI Law are capturing them right now while this firm’s paid presence sits empty.”</a:t>
             </a:r>
           </a:p>
         </p:txBody>

</xml_diff>